<commit_message>
Update seminar PDFs/PPTXs (03.23, 03.30, 04.06, 04.13)
</commit_message>
<xml_diff>
--- a/assets/files/26.03.23.세미나.pptx
+++ b/assets/files/26.03.23.세미나.pptx
@@ -250,18 +250,10 @@
       <p15:sldGuideLst xmlns:p15="http://schemas.microsoft.com/office/powerpoint/2012/main"/>
     </p:ext>
     <p:ext uri="http://customooxmlschemas.google.com/">
-      <go:slidesCustomData xmlns="" xmlns:mc="http://schemas.openxmlformats.org/markup-compatibility/2006" xmlns:mv="urn:schemas-microsoft-com:mac:vml" xmlns:c="http://schemas.openxmlformats.org/drawingml/2006/chart" xmlns:dgm="http://schemas.openxmlformats.org/drawingml/2006/diagram" xmlns:o="urn:schemas-microsoft-com:office:office" xmlns:v="urn:schemas-microsoft-com:vml" xmlns:pvml="urn:schemas-microsoft-com:office:powerpoint" xmlns:com="http://schemas.openxmlformats.org/drawingml/2006/compatibility" xmlns:p14="http://schemas.microsoft.com/office/powerpoint/2010/main" xmlns:p15="http://schemas.microsoft.com/office/powerpoint/2012/main" xmlns:ahyp="http://schemas.microsoft.com/office/drawing/2018/hyperlinkcolor" xmlns:go="http://customooxmlschemas.google.com/" r:id="rId119" roundtripDataSignature="AMtx7mi60wwQBXdufn43yw7rgc2Btalb6Q=="/>
+      <go:slidesCustomData xmlns:go="http://customooxmlschemas.google.com/" xmlns:ahyp="http://schemas.microsoft.com/office/drawing/2018/hyperlinkcolor" xmlns:p15="http://schemas.microsoft.com/office/powerpoint/2012/main" xmlns:p14="http://schemas.microsoft.com/office/powerpoint/2010/main" xmlns:com="http://schemas.openxmlformats.org/drawingml/2006/compatibility" xmlns:pvml="urn:schemas-microsoft-com:office:powerpoint" xmlns:v="urn:schemas-microsoft-com:vml" xmlns:o="urn:schemas-microsoft-com:office:office" xmlns:dgm="http://schemas.openxmlformats.org/drawingml/2006/diagram" xmlns:c="http://schemas.openxmlformats.org/drawingml/2006/chart" xmlns:mv="urn:schemas-microsoft-com:mac:vml" xmlns:mc="http://schemas.openxmlformats.org/markup-compatibility/2006" xmlns="" r:id="rId119" roundtripDataSignature="AMtx7mi60wwQBXdufn43yw7rgc2Btalb6Q=="/>
     </p:ext>
   </p:extLst>
 </p:presentation>
-</file>
-
-<file path=ppt/revisionInfo.xml><?xml version="1.0" encoding="utf-8"?>
-<p1510:revInfo xmlns:a="http://schemas.openxmlformats.org/drawingml/2006/main" xmlns:r="http://schemas.openxmlformats.org/officeDocument/2006/relationships" xmlns:p1510="http://schemas.microsoft.com/office/powerpoint/2015/10/main">
-  <p1510:revLst>
-    <p1510:client id="{E07F7820-734E-4EEF-8B05-DACDCB4A974A}" v="3" dt="2026-03-22T17:45:43.653"/>
-  </p1510:revLst>
-</p1510:revInfo>
 </file>
 
 <file path=ppt/changesInfos/changesInfo1.xml><?xml version="1.0" encoding="utf-8"?>
@@ -269,99 +261,22 @@
   <pc:docChgLst>
     <pc:chgData name="성우 최" userId="b39b9c6800b01a47" providerId="LiveId" clId="{86918D44-C542-442D-8291-F46EC03904AF}"/>
     <pc:docChg chg="undo custSel addSld delSld modSld">
-      <pc:chgData name="성우 최" userId="b39b9c6800b01a47" providerId="LiveId" clId="{86918D44-C542-442D-8291-F46EC03904AF}" dt="2026-03-23T05:59:15.813" v="1149" actId="47"/>
+      <pc:chgData name="성우 최" userId="b39b9c6800b01a47" providerId="LiveId" clId="{86918D44-C542-442D-8291-F46EC03904AF}" dt="2026-05-19T17:40:52.520" v="1155" actId="5793"/>
       <pc:docMkLst>
         <pc:docMk/>
       </pc:docMkLst>
-      <pc:sldChg chg="modSp mod">
-        <pc:chgData name="성우 최" userId="b39b9c6800b01a47" providerId="LiveId" clId="{86918D44-C542-442D-8291-F46EC03904AF}" dt="2026-03-22T17:42:08.490" v="385" actId="5793"/>
-        <pc:sldMkLst>
-          <pc:docMk/>
-          <pc:sldMk cId="803715702" sldId="629"/>
-        </pc:sldMkLst>
-        <pc:spChg chg="mod">
-          <ac:chgData name="성우 최" userId="b39b9c6800b01a47" providerId="LiveId" clId="{86918D44-C542-442D-8291-F46EC03904AF}" dt="2026-03-22T17:42:08.490" v="385" actId="5793"/>
-          <ac:spMkLst>
-            <pc:docMk/>
-            <pc:sldMk cId="803715702" sldId="629"/>
-            <ac:spMk id="6" creationId="{1A1337AF-AF8B-E25C-422F-9E73A6256CF9}"/>
-          </ac:spMkLst>
-        </pc:spChg>
-      </pc:sldChg>
-      <pc:sldChg chg="modSp mod">
-        <pc:chgData name="성우 최" userId="b39b9c6800b01a47" providerId="LiveId" clId="{86918D44-C542-442D-8291-F46EC03904AF}" dt="2026-03-22T17:44:06.658" v="764" actId="20577"/>
-        <pc:sldMkLst>
-          <pc:docMk/>
-          <pc:sldMk cId="2217391575" sldId="630"/>
-        </pc:sldMkLst>
-        <pc:spChg chg="mod">
-          <ac:chgData name="성우 최" userId="b39b9c6800b01a47" providerId="LiveId" clId="{86918D44-C542-442D-8291-F46EC03904AF}" dt="2026-03-22T17:42:24.406" v="425" actId="20577"/>
-          <ac:spMkLst>
-            <pc:docMk/>
-            <pc:sldMk cId="2217391575" sldId="630"/>
-            <ac:spMk id="2" creationId="{640EEAB2-05ED-EFA4-304E-1B569979A9DF}"/>
-          </ac:spMkLst>
-        </pc:spChg>
-        <pc:spChg chg="mod">
-          <ac:chgData name="성우 최" userId="b39b9c6800b01a47" providerId="LiveId" clId="{86918D44-C542-442D-8291-F46EC03904AF}" dt="2026-03-22T17:44:06.658" v="764" actId="20577"/>
-          <ac:spMkLst>
-            <pc:docMk/>
-            <pc:sldMk cId="2217391575" sldId="630"/>
-            <ac:spMk id="6" creationId="{9050618A-3C38-D5D0-A5B7-BC5902EAD7C3}"/>
-          </ac:spMkLst>
-        </pc:spChg>
-      </pc:sldChg>
       <pc:sldChg chg="addSp delSp modSp mod">
-        <pc:chgData name="성우 최" userId="b39b9c6800b01a47" providerId="LiveId" clId="{86918D44-C542-442D-8291-F46EC03904AF}" dt="2026-03-22T17:44:58.928" v="908" actId="22"/>
+        <pc:chgData name="성우 최" userId="b39b9c6800b01a47" providerId="LiveId" clId="{86918D44-C542-442D-8291-F46EC03904AF}" dt="2026-05-19T17:40:52.520" v="1155" actId="5793"/>
         <pc:sldMkLst>
           <pc:docMk/>
           <pc:sldMk cId="2754075215" sldId="631"/>
         </pc:sldMkLst>
         <pc:spChg chg="mod">
-          <ac:chgData name="성우 최" userId="b39b9c6800b01a47" providerId="LiveId" clId="{86918D44-C542-442D-8291-F46EC03904AF}" dt="2026-03-22T17:44:14.099" v="796" actId="20577"/>
-          <ac:spMkLst>
-            <pc:docMk/>
-            <pc:sldMk cId="2754075215" sldId="631"/>
-            <ac:spMk id="2" creationId="{0CAFB6E3-7493-FC3B-8455-D76DBC131F4D}"/>
-          </ac:spMkLst>
-        </pc:spChg>
-        <pc:spChg chg="add del">
-          <ac:chgData name="성우 최" userId="b39b9c6800b01a47" providerId="LiveId" clId="{86918D44-C542-442D-8291-F46EC03904AF}" dt="2026-03-22T17:44:58.928" v="908" actId="22"/>
-          <ac:spMkLst>
-            <pc:docMk/>
-            <pc:sldMk cId="2754075215" sldId="631"/>
-            <ac:spMk id="4" creationId="{7CE7EC62-C7CB-EE7F-AA38-6BE759BD0600}"/>
-          </ac:spMkLst>
-        </pc:spChg>
-        <pc:spChg chg="mod">
-          <ac:chgData name="성우 최" userId="b39b9c6800b01a47" providerId="LiveId" clId="{86918D44-C542-442D-8291-F46EC03904AF}" dt="2026-03-22T17:44:51.982" v="906" actId="20577"/>
+          <ac:chgData name="성우 최" userId="b39b9c6800b01a47" providerId="LiveId" clId="{86918D44-C542-442D-8291-F46EC03904AF}" dt="2026-05-19T17:40:52.520" v="1155" actId="5793"/>
           <ac:spMkLst>
             <pc:docMk/>
             <pc:sldMk cId="2754075215" sldId="631"/>
             <ac:spMk id="6" creationId="{A956C7E1-7399-405A-D965-D6C7C4AAF12A}"/>
-          </ac:spMkLst>
-        </pc:spChg>
-      </pc:sldChg>
-      <pc:sldChg chg="modSp add del mod">
-        <pc:chgData name="성우 최" userId="b39b9c6800b01a47" providerId="LiveId" clId="{86918D44-C542-442D-8291-F46EC03904AF}" dt="2026-03-23T05:59:15.813" v="1149" actId="47"/>
-        <pc:sldMkLst>
-          <pc:docMk/>
-          <pc:sldMk cId="1432759077" sldId="632"/>
-        </pc:sldMkLst>
-        <pc:spChg chg="mod">
-          <ac:chgData name="성우 최" userId="b39b9c6800b01a47" providerId="LiveId" clId="{86918D44-C542-442D-8291-F46EC03904AF}" dt="2026-03-22T17:45:32.995" v="989" actId="20577"/>
-          <ac:spMkLst>
-            <pc:docMk/>
-            <pc:sldMk cId="1432759077" sldId="632"/>
-            <ac:spMk id="2" creationId="{A82C633E-3D38-E759-68DF-F8ADBE17960F}"/>
-          </ac:spMkLst>
-        </pc:spChg>
-        <pc:spChg chg="mod">
-          <ac:chgData name="성우 최" userId="b39b9c6800b01a47" providerId="LiveId" clId="{86918D44-C542-442D-8291-F46EC03904AF}" dt="2026-03-22T17:46:13.889" v="1148" actId="20577"/>
-          <ac:spMkLst>
-            <pc:docMk/>
-            <pc:sldMk cId="1432759077" sldId="632"/>
-            <ac:spMk id="6" creationId="{FD5E556D-6BD7-96CF-8B71-E91E8BF88BA0}"/>
           </ac:spMkLst>
         </pc:spChg>
       </pc:sldChg>
@@ -12223,22 +12138,20 @@
             </a:endParaRPr>
           </a:p>
           <a:p>
-            <a:pPr lvl="1">
+            <a:pPr marL="571500" lvl="1" indent="0">
               <a:lnSpc>
                 <a:spcPct val="150000"/>
               </a:lnSpc>
+              <a:buNone/>
               <a:defRPr/>
             </a:pPr>
-            <a:r>
-              <a:rPr lang="en-US" altLang="ko-KR" sz="1600" dirty="0">
-                <a:solidFill>
-                  <a:schemeClr val="tx1"/>
-                </a:solidFill>
-                <a:latin typeface="Calibri" panose="020F0502020204030204" pitchFamily="34" charset="0"/>
-                <a:cs typeface="Calibri" panose="020F0502020204030204" pitchFamily="34" charset="0"/>
-              </a:rPr>
-              <a:t>~~~~~</a:t>
-            </a:r>
+            <a:endParaRPr lang="en-US" altLang="ko-KR" sz="1600" dirty="0">
+              <a:solidFill>
+                <a:schemeClr val="tx1"/>
+              </a:solidFill>
+              <a:latin typeface="Calibri" panose="020F0502020204030204" pitchFamily="34" charset="0"/>
+              <a:cs typeface="Calibri" panose="020F0502020204030204" pitchFamily="34" charset="0"/>
+            </a:endParaRPr>
           </a:p>
         </p:txBody>
       </p:sp>

</xml_diff>